<commit_message>
update second slide arrow
</commit_message>
<xml_diff>
--- a/submission/presentation_group18.pptx
+++ b/submission/presentation_group18.pptx
@@ -4358,7 +4358,7 @@
               </a:defRPr>
             </a:pPr>
             <a:r>
-              <a:rPr sz="1200" b="0">
+              <a:rPr sz="1200" b="0" dirty="0">
                 <a:solidFill>
                   <a:srgbClr val="5E5E5D"/>
                 </a:solidFill>
@@ -4384,7 +4384,7 @@
         </p:nvSpPr>
         <p:spPr>
           <a:xfrm>
-            <a:off x="838200" y="2857500"/>
+            <a:off x="838200" y="2570779"/>
             <a:ext cx="2095500" cy="228600"/>
           </a:xfrm>
           <a:prstGeom prst="rect">
@@ -4416,7 +4416,7 @@
               </a:defRPr>
             </a:pPr>
             <a:r>
-              <a:rPr sz="1350" b="1">
+              <a:rPr sz="1350" b="1" dirty="0">
                 <a:solidFill>
                   <a:srgbClr val="1F252B"/>
                 </a:solidFill>
@@ -4442,7 +4442,7 @@
         </p:nvSpPr>
         <p:spPr>
           <a:xfrm>
-            <a:off x="838200" y="3162300"/>
+            <a:off x="838200" y="2875579"/>
             <a:ext cx="4191000" cy="685800"/>
           </a:xfrm>
           <a:prstGeom prst="roundRect">
@@ -4484,7 +4484,7 @@
         </p:nvSpPr>
         <p:spPr>
           <a:xfrm>
-            <a:off x="838200" y="3162300"/>
+            <a:off x="838200" y="2875579"/>
             <a:ext cx="66675" cy="685800"/>
           </a:xfrm>
           <a:prstGeom prst="rect">
@@ -4526,7 +4526,7 @@
         </p:nvSpPr>
         <p:spPr>
           <a:xfrm>
-            <a:off x="1009650" y="3324225"/>
+            <a:off x="1009650" y="3037504"/>
             <a:ext cx="304800" cy="285750"/>
           </a:xfrm>
           <a:prstGeom prst="rect">
@@ -4584,7 +4584,7 @@
         </p:nvSpPr>
         <p:spPr>
           <a:xfrm>
-            <a:off x="1428750" y="3295650"/>
+            <a:off x="1428750" y="3008929"/>
             <a:ext cx="3390900" cy="228600"/>
           </a:xfrm>
           <a:prstGeom prst="rect">
@@ -4644,7 +4644,7 @@
         </p:nvSpPr>
         <p:spPr>
           <a:xfrm>
-            <a:off x="1428750" y="3543300"/>
+            <a:off x="1428750" y="3256579"/>
             <a:ext cx="3390900" cy="247650"/>
           </a:xfrm>
           <a:prstGeom prst="rect">
@@ -4678,12 +4678,44 @@
               </a:defRPr>
             </a:pPr>
             <a:r>
-              <a:rPr sz="825" b="0">
+              <a:rPr sz="825" b="0" dirty="0">
                 <a:solidFill>
                   <a:srgbClr val="5E5E5D"/>
                 </a:solidFill>
               </a:rPr>
-              <a:t>Ridge, RandomForest, XGBoost and MLP cover the required linear, tree-based and neural-network approaches.</a:t>
+              <a:t>Ridge, </a:t>
+            </a:r>
+            <a:r>
+              <a:rPr sz="825" b="0" dirty="0" err="1">
+                <a:solidFill>
+                  <a:srgbClr val="5E5E5D"/>
+                </a:solidFill>
+              </a:rPr>
+              <a:t>RandomForest</a:t>
+            </a:r>
+            <a:r>
+              <a:rPr sz="825" b="0" dirty="0">
+                <a:solidFill>
+                  <a:srgbClr val="5E5E5D"/>
+                </a:solidFill>
+              </a:rPr>
+              <a:t>, </a:t>
+            </a:r>
+            <a:r>
+              <a:rPr sz="825" b="0" dirty="0" err="1">
+                <a:solidFill>
+                  <a:srgbClr val="5E5E5D"/>
+                </a:solidFill>
+              </a:rPr>
+              <a:t>XGBoost</a:t>
+            </a:r>
+            <a:r>
+              <a:rPr sz="825" b="0" dirty="0">
+                <a:solidFill>
+                  <a:srgbClr val="5E5E5D"/>
+                </a:solidFill>
+              </a:rPr>
+              <a:t> and MLP cover the required linear, tree-based and neural-network approaches.</a:t>
             </a:r>
           </a:p>
         </p:txBody>
@@ -4704,7 +4736,7 @@
         </p:nvSpPr>
         <p:spPr>
           <a:xfrm>
-            <a:off x="2895600" y="3905250"/>
+            <a:off x="2895600" y="3618529"/>
             <a:ext cx="323850" cy="228600"/>
           </a:xfrm>
           <a:prstGeom prst="downArrow">
@@ -4744,7 +4776,7 @@
         </p:nvSpPr>
         <p:spPr>
           <a:xfrm>
-            <a:off x="1200150" y="4171950"/>
+            <a:off x="1200150" y="3885229"/>
             <a:ext cx="3467100" cy="647700"/>
           </a:xfrm>
           <a:prstGeom prst="roundRect">
@@ -4786,7 +4818,7 @@
         </p:nvSpPr>
         <p:spPr>
           <a:xfrm>
-            <a:off x="1200150" y="4171950"/>
+            <a:off x="1200150" y="3885229"/>
             <a:ext cx="66675" cy="647700"/>
           </a:xfrm>
           <a:prstGeom prst="rect">
@@ -4828,7 +4860,7 @@
         </p:nvSpPr>
         <p:spPr>
           <a:xfrm>
-            <a:off x="1371600" y="4333875"/>
+            <a:off x="1371600" y="4047154"/>
             <a:ext cx="304800" cy="285750"/>
           </a:xfrm>
           <a:prstGeom prst="rect">
@@ -4886,7 +4918,7 @@
         </p:nvSpPr>
         <p:spPr>
           <a:xfrm>
-            <a:off x="1790700" y="4305300"/>
+            <a:off x="1790700" y="4018579"/>
             <a:ext cx="2667000" cy="228600"/>
           </a:xfrm>
           <a:prstGeom prst="rect">
@@ -4946,7 +4978,7 @@
         </p:nvSpPr>
         <p:spPr>
           <a:xfrm>
-            <a:off x="1790700" y="4552950"/>
+            <a:off x="1790700" y="4266229"/>
             <a:ext cx="2667000" cy="209550"/>
           </a:xfrm>
           <a:prstGeom prst="rect">
@@ -4980,12 +5012,20 @@
               </a:defRPr>
             </a:pPr>
             <a:r>
-              <a:rPr sz="825" b="0">
+              <a:rPr sz="825" b="0" dirty="0" err="1">
                 <a:solidFill>
                   <a:srgbClr val="5E5E5D"/>
                 </a:solidFill>
               </a:rPr>
-              <a:t>XGBoost is strongest across the rolling validation windows.</a:t>
+              <a:t>XGBoost</a:t>
+            </a:r>
+            <a:r>
+              <a:rPr sz="825" b="0" dirty="0">
+                <a:solidFill>
+                  <a:srgbClr val="5E5E5D"/>
+                </a:solidFill>
+              </a:rPr>
+              <a:t> is strongest across the rolling validation windows.</a:t>
             </a:r>
           </a:p>
         </p:txBody>
@@ -5006,7 +5046,7 @@
         </p:nvSpPr>
         <p:spPr>
           <a:xfrm>
-            <a:off x="2895600" y="4876800"/>
+            <a:off x="2895600" y="4590079"/>
             <a:ext cx="323850" cy="228600"/>
           </a:xfrm>
           <a:prstGeom prst="downArrow">
@@ -5046,7 +5086,7 @@
         </p:nvSpPr>
         <p:spPr>
           <a:xfrm>
-            <a:off x="1562100" y="5067300"/>
+            <a:off x="1562100" y="4873567"/>
             <a:ext cx="2743200" cy="647700"/>
           </a:xfrm>
           <a:prstGeom prst="roundRect">
@@ -5088,7 +5128,7 @@
         </p:nvSpPr>
         <p:spPr>
           <a:xfrm>
-            <a:off x="1562100" y="5067300"/>
+            <a:off x="1562100" y="4873567"/>
             <a:ext cx="66675" cy="647700"/>
           </a:xfrm>
           <a:prstGeom prst="rect">
@@ -5130,7 +5170,7 @@
         </p:nvSpPr>
         <p:spPr>
           <a:xfrm>
-            <a:off x="1733550" y="5229225"/>
+            <a:off x="1733550" y="5035492"/>
             <a:ext cx="304800" cy="285750"/>
           </a:xfrm>
           <a:prstGeom prst="rect">
@@ -5188,7 +5228,7 @@
         </p:nvSpPr>
         <p:spPr>
           <a:xfrm>
-            <a:off x="2152650" y="5200650"/>
+            <a:off x="2152650" y="5006917"/>
             <a:ext cx="1943100" cy="228600"/>
           </a:xfrm>
           <a:prstGeom prst="rect">
@@ -5248,7 +5288,7 @@
         </p:nvSpPr>
         <p:spPr>
           <a:xfrm>
-            <a:off x="2152650" y="5448300"/>
+            <a:off x="2152650" y="5254567"/>
             <a:ext cx="1943100" cy="209550"/>
           </a:xfrm>
           <a:prstGeom prst="rect">
@@ -5270,7 +5310,7 @@
         </p:spPr>
         <p:txBody>
           <a:bodyPr lIns="0" tIns="0" rIns="0" bIns="0" anchor="t">
-            <a:normAutofit fontScale="83823"/>
+            <a:normAutofit fontScale="91323" lnSpcReduction="20000"/>
           </a:bodyPr>
           <a:lstStyle/>
           <a:p>
@@ -5282,12 +5322,44 @@
               </a:defRPr>
             </a:pPr>
             <a:r>
-              <a:rPr sz="825" b="0">
+              <a:rPr sz="825" b="0" dirty="0">
                 <a:solidFill>
                   <a:srgbClr val="5E5E5D"/>
                 </a:solidFill>
               </a:rPr>
-              <a:t>Test XGBoost variants, including adjusted tree settings and log1p(BikeCount).</a:t>
+              <a:t>Test </a:t>
+            </a:r>
+            <a:r>
+              <a:rPr sz="825" b="0" dirty="0" err="1">
+                <a:solidFill>
+                  <a:srgbClr val="5E5E5D"/>
+                </a:solidFill>
+              </a:rPr>
+              <a:t>XGBoost</a:t>
+            </a:r>
+            <a:r>
+              <a:rPr sz="825" b="0" dirty="0">
+                <a:solidFill>
+                  <a:srgbClr val="5E5E5D"/>
+                </a:solidFill>
+              </a:rPr>
+              <a:t> variants, including adjusted tree settings and log1p(</a:t>
+            </a:r>
+            <a:r>
+              <a:rPr sz="825" b="0" dirty="0" err="1">
+                <a:solidFill>
+                  <a:srgbClr val="5E5E5D"/>
+                </a:solidFill>
+              </a:rPr>
+              <a:t>BikeCount</a:t>
+            </a:r>
+            <a:r>
+              <a:rPr sz="825" b="0" dirty="0">
+                <a:solidFill>
+                  <a:srgbClr val="5E5E5D"/>
+                </a:solidFill>
+              </a:rPr>
+              <a:t>).</a:t>
             </a:r>
           </a:p>
         </p:txBody>
@@ -6148,7 +6220,7 @@
         </p:nvSpPr>
         <p:spPr>
           <a:xfrm>
-            <a:off x="5829300" y="3724275"/>
+            <a:off x="5829300" y="3755271"/>
             <a:ext cx="2476500" cy="171450"/>
           </a:xfrm>
           <a:prstGeom prst="rect">
@@ -6180,7 +6252,7 @@
               </a:defRPr>
             </a:pPr>
             <a:r>
-              <a:rPr sz="750" b="1">
+              <a:rPr sz="750" b="1" dirty="0">
                 <a:solidFill>
                   <a:srgbClr val="5E5E5D"/>
                 </a:solidFill>
@@ -7164,7 +7236,7 @@
         </p:nvSpPr>
         <p:spPr>
           <a:xfrm>
-            <a:off x="5829300" y="4848225"/>
+            <a:off x="5829300" y="4894719"/>
             <a:ext cx="2476500" cy="171450"/>
           </a:xfrm>
           <a:prstGeom prst="rect">
@@ -7196,7 +7268,7 @@
               </a:defRPr>
             </a:pPr>
             <a:r>
-              <a:rPr sz="750" b="1">
+              <a:rPr sz="750" b="1" dirty="0">
                 <a:solidFill>
                   <a:srgbClr val="5E5E5D"/>
                 </a:solidFill>
@@ -8052,12 +8124,28 @@
               </a:defRPr>
             </a:pPr>
             <a:r>
-              <a:rPr sz="975" b="1">
+              <a:rPr sz="975" b="1" dirty="0">
                 <a:solidFill>
                   <a:srgbClr val="1F252B"/>
                 </a:solidFill>
               </a:rPr>
-              <a:t>Boosted trees fit this tabular time-series task best; XGBoost tuned achieves the lowest rolling validation error on both horizons.</a:t>
+              <a:t>Boosted trees fit this tabular time-series task best; </a:t>
+            </a:r>
+            <a:r>
+              <a:rPr sz="975" b="1" dirty="0" err="1">
+                <a:solidFill>
+                  <a:srgbClr val="1F252B"/>
+                </a:solidFill>
+              </a:rPr>
+              <a:t>XGBoost</a:t>
+            </a:r>
+            <a:r>
+              <a:rPr sz="975" b="1" dirty="0">
+                <a:solidFill>
+                  <a:srgbClr val="1F252B"/>
+                </a:solidFill>
+              </a:rPr>
+              <a:t> tuned achieves the lowest rolling validation error on both horizons.</a:t>
             </a:r>
           </a:p>
         </p:txBody>

</xml_diff>